<commit_message>
Week 6: add 'The whole transformer' one-pass summary slide (after Full circle)
Single-slide end-to-end flow: review -> tokens -> embeddings+positions ->
transformer block x12 (attention/FFN with add&norm) -> LM head -> next token,
with the autoregressive loop back to the input. Deck now 18 slides.

Co-Authored-By: Claude Opus 4.8 <noreply@anthropic.com>
</commit_message>
<xml_diff>
--- a/Week 6/L11_Forward_BuildItUp.pptx
+++ b/Week 6/L11_Forward_BuildItUp.pptx
@@ -22,6 +22,7 @@
     <p:sldId id="270" r:id="rId21"/>
     <p:sldId id="271" r:id="rId22"/>
     <p:sldId id="272" r:id="rId23"/>
+    <p:sldId id="273" r:id="rId24"/>
   </p:sldIdLst>
   <p:sldSz cx="12191695" cy="6858000" type="screen4x3"/>
   <p:notesSz cx="6858000" cy="9144000"/>
@@ -6085,7 +6086,7 @@
                 </a:solidFill>
                 <a:latin typeface="Helvetica Neue"/>
               </a:rPr>
-              <a:t>AT SCALE</a:t>
+              <a:t>THE WHOLE TRANSFORMER</a:t>
             </a:r>
           </a:p>
         </p:txBody>
@@ -6120,7 +6121,7 @@
                 </a:solidFill>
                 <a:latin typeface="Helvetica Neue"/>
               </a:rPr>
-              <a:t>What makes production models fast and long.</a:t>
+              <a:t>One full pass, end to end.</a:t>
             </a:r>
           </a:p>
         </p:txBody>
@@ -6155,7 +6156,7 @@
                 </a:solidFill>
                 <a:latin typeface="Helvetica Neue"/>
               </a:rPr>
-              <a:t>The 2017 mechanism, plus a decade of engineering to serve millions of tokens.</a:t>
+              <a:t>Text becomes tokens, then vectors; the stack refines them; the head names the next word; the loop writes the rest.</a:t>
             </a:r>
           </a:p>
         </p:txBody>
@@ -6197,7 +6198,7 @@
       </p:sp>
       <p:pic>
         <p:nvPicPr>
-          <p:cNvPr id="6" name="Picture 5" descr="hy_scale.png"/>
+          <p:cNvPr id="6" name="Picture 5" descr="ff_flow.png"/>
           <p:cNvPicPr>
             <a:picLocks noChangeAspect="1"/>
           </p:cNvPicPr>
@@ -6211,8 +6212,8 @@
         </p:blipFill>
         <p:spPr>
           <a:xfrm>
-            <a:off x="518007" y="2286000"/>
-            <a:ext cx="11155680" cy="2092264"/>
+            <a:off x="518007" y="2926080"/>
+            <a:ext cx="11155680" cy="2592621"/>
           </a:xfrm>
           <a:prstGeom prst="rect">
             <a:avLst/>
@@ -6267,7 +6268,7 @@
                 </a:solidFill>
                 <a:latin typeface="Helvetica Neue"/>
               </a:rPr>
-              <a:t>MODEL FAMILIES</a:t>
+              <a:t>AT SCALE</a:t>
             </a:r>
           </a:p>
         </p:txBody>
@@ -6302,7 +6303,7 @@
                 </a:solidFill>
                 <a:latin typeface="Helvetica Neue"/>
               </a:rPr>
-              <a:t>Encoder, decoder, encoder-decoder.</a:t>
+              <a:t>What makes production models fast and long.</a:t>
             </a:r>
           </a:p>
         </p:txBody>
@@ -6337,7 +6338,7 @@
                 </a:solidFill>
                 <a:latin typeface="Helvetica Neue"/>
               </a:rPr>
-              <a:t>Every transformer is one of three shapes. You have already used two of them.</a:t>
+              <a:t>The 2017 mechanism, plus a decade of engineering to serve millions of tokens.</a:t>
             </a:r>
           </a:p>
         </p:txBody>
@@ -6379,7 +6380,7 @@
       </p:sp>
       <p:pic>
         <p:nvPicPr>
-          <p:cNvPr id="6" name="Picture 5" descr="hy_family.png"/>
+          <p:cNvPr id="6" name="Picture 5" descr="hy_scale.png"/>
           <p:cNvPicPr>
             <a:picLocks noChangeAspect="1"/>
           </p:cNvPicPr>
@@ -6393,49 +6394,14 @@
         </p:blipFill>
         <p:spPr>
           <a:xfrm>
-            <a:off x="518007" y="2331720"/>
-            <a:ext cx="11155680" cy="1792224"/>
+            <a:off x="518007" y="2286000"/>
+            <a:ext cx="11155680" cy="2092264"/>
           </a:xfrm>
           <a:prstGeom prst="rect">
             <a:avLst/>
           </a:prstGeom>
         </p:spPr>
       </p:pic>
-      <p:sp>
-        <p:nvSpPr>
-          <p:cNvPr id="7" name="TextBox 6"/>
-          <p:cNvSpPr txBox="1"/>
-          <p:nvPr/>
-        </p:nvSpPr>
-        <p:spPr>
-          <a:xfrm>
-            <a:off x="640080" y="5577840"/>
-            <a:ext cx="10881360" cy="457200"/>
-          </a:xfrm>
-          <a:prstGeom prst="rect">
-            <a:avLst/>
-          </a:prstGeom>
-          <a:noFill/>
-        </p:spPr>
-        <p:txBody>
-          <a:bodyPr wrap="square">
-            <a:spAutoFit/>
-          </a:bodyPr>
-          <a:lstStyle/>
-          <a:p>
-            <a:pPr algn="ctr"/>
-            <a:r>
-              <a:rPr sz="1400" b="0" i="1">
-                <a:solidFill>
-                  <a:srgbClr val="475569"/>
-                </a:solidFill>
-                <a:latin typeface="Helvetica Neue"/>
-              </a:rPr>
-              <a:t>Same block, same attention. What differs is whether the model looks only backward (to generate) or at the whole input at once (to read).</a:t>
-            </a:r>
-          </a:p>
-        </p:txBody>
-      </p:sp>
     </p:spTree>
   </p:cSld>
   <p:clrMapOvr>
@@ -6484,7 +6450,7 @@
                 </a:solidFill>
                 <a:latin typeface="Helvetica Neue"/>
               </a:rPr>
-              <a:t>THE TAKEAWAY</a:t>
+              <a:t>MODEL FAMILIES</a:t>
             </a:r>
           </a:p>
         </p:txBody>
@@ -6519,7 +6485,7 @@
                 </a:solidFill>
                 <a:latin typeface="Helvetica Neue"/>
               </a:rPr>
-              <a:t>You can now name every step.</a:t>
+              <a:t>Encoder, decoder, encoder-decoder.</a:t>
             </a:r>
           </a:p>
         </p:txBody>
@@ -6527,6 +6493,41 @@
       <p:sp>
         <p:nvSpPr>
           <p:cNvPr id="4" name="TextBox 3"/>
+          <p:cNvSpPr txBox="1"/>
+          <p:nvPr/>
+        </p:nvSpPr>
+        <p:spPr>
+          <a:xfrm>
+            <a:off x="640080" y="1417320"/>
+            <a:ext cx="10424160" cy="457200"/>
+          </a:xfrm>
+          <a:prstGeom prst="rect">
+            <a:avLst/>
+          </a:prstGeom>
+          <a:noFill/>
+        </p:spPr>
+        <p:txBody>
+          <a:bodyPr wrap="square">
+            <a:spAutoFit/>
+          </a:bodyPr>
+          <a:lstStyle/>
+          <a:p>
+            <a:pPr algn="l"/>
+            <a:r>
+              <a:rPr sz="1500" b="0" i="0">
+                <a:solidFill>
+                  <a:srgbClr val="475569"/>
+                </a:solidFill>
+                <a:latin typeface="Helvetica Neue"/>
+              </a:rPr>
+              <a:t>Every transformer is one of three shapes. You have already used two of them.</a:t>
+            </a:r>
+          </a:p>
+        </p:txBody>
+      </p:sp>
+      <p:sp>
+        <p:nvSpPr>
+          <p:cNvPr id="5" name="TextBox 4"/>
           <p:cNvSpPr txBox="1"/>
           <p:nvPr/>
         </p:nvSpPr>
@@ -6561,7 +6562,7 @@
       </p:sp>
       <p:pic>
         <p:nvPicPr>
-          <p:cNvPr id="5" name="Picture 4" descr="hy_close.png"/>
+          <p:cNvPr id="6" name="Picture 5" descr="hy_family.png"/>
           <p:cNvPicPr>
             <a:picLocks noChangeAspect="1"/>
           </p:cNvPicPr>
@@ -6575,8 +6576,8 @@
         </p:blipFill>
         <p:spPr>
           <a:xfrm>
-            <a:off x="184251" y="2194560"/>
-            <a:ext cx="11823192" cy="631201"/>
+            <a:off x="518007" y="2331720"/>
+            <a:ext cx="11155680" cy="1792224"/>
           </a:xfrm>
           <a:prstGeom prst="rect">
             <a:avLst/>
@@ -6585,113 +6586,35 @@
       </p:pic>
       <p:sp>
         <p:nvSpPr>
-          <p:cNvPr id="6" name="TextBox 5"/>
-          <p:cNvSpPr txBox="1"/>
-          <p:nvPr/>
-        </p:nvSpPr>
-        <p:spPr>
-          <a:xfrm>
-            <a:off x="640080" y="3337560"/>
-            <a:ext cx="10607040" cy="914400"/>
-          </a:xfrm>
-          <a:prstGeom prst="rect">
-            <a:avLst/>
-          </a:prstGeom>
-          <a:noFill/>
-        </p:spPr>
-        <p:txBody>
-          <a:bodyPr wrap="square">
-            <a:spAutoFit/>
-          </a:bodyPr>
-          <a:lstStyle/>
-          <a:p>
-            <a:pPr algn="l"/>
-            <a:r>
-              <a:rPr sz="1700" b="0" i="0">
-                <a:solidFill>
-                  <a:srgbClr val="334155"/>
-                </a:solidFill>
-                <a:latin typeface="Helvetica Neue"/>
-              </a:rPr>
-              <a:t>One cost to carry forward: every token attends to every other token, so the work grows with the square of the sequence length. That is why context windows are precious, and it is next week's problem: retrieval and RAG.</a:t>
-            </a:r>
-          </a:p>
-        </p:txBody>
-      </p:sp>
-      <p:sp>
-        <p:nvSpPr>
-          <p:cNvPr id="7" name="Rectangle 6"/>
-          <p:cNvSpPr/>
-          <p:nvPr/>
-        </p:nvSpPr>
-        <p:spPr>
-          <a:xfrm>
-            <a:off x="658368" y="4617720"/>
-            <a:ext cx="822960" cy="54864"/>
-          </a:xfrm>
-          <a:prstGeom prst="rect">
-            <a:avLst/>
-          </a:prstGeom>
-          <a:solidFill>
-            <a:srgbClr val="E11D48"/>
-          </a:solidFill>
-          <a:ln>
-            <a:noFill/>
-          </a:ln>
-        </p:spPr>
-        <p:style>
-          <a:lnRef idx="1">
-            <a:schemeClr val="accent1"/>
-          </a:lnRef>
-          <a:fillRef idx="3">
-            <a:schemeClr val="accent1"/>
-          </a:fillRef>
-          <a:effectRef idx="2">
-            <a:schemeClr val="accent1"/>
-          </a:effectRef>
-          <a:fontRef idx="minor">
-            <a:schemeClr val="lt1"/>
-          </a:fontRef>
-        </p:style>
-        <p:txBody>
-          <a:bodyPr rtlCol="0" anchor="ctr"/>
-          <a:lstStyle/>
-          <a:p>
-            <a:pPr algn="ctr"/>
-          </a:p>
-        </p:txBody>
-      </p:sp>
-      <p:sp>
-        <p:nvSpPr>
-          <p:cNvPr id="8" name="TextBox 7"/>
-          <p:cNvSpPr txBox="1"/>
-          <p:nvPr/>
-        </p:nvSpPr>
-        <p:spPr>
-          <a:xfrm>
-            <a:off x="640080" y="4800600"/>
-            <a:ext cx="10515600" cy="457200"/>
-          </a:xfrm>
-          <a:prstGeom prst="rect">
-            <a:avLst/>
-          </a:prstGeom>
-          <a:noFill/>
-        </p:spPr>
-        <p:txBody>
-          <a:bodyPr wrap="square">
-            <a:spAutoFit/>
-          </a:bodyPr>
-          <a:lstStyle/>
-          <a:p>
-            <a:pPr algn="l"/>
-            <a:r>
-              <a:rPr sz="1700" b="0" i="1">
-                <a:solidFill>
-                  <a:srgbClr val="0F172A"/>
-                </a:solidFill>
-                <a:latin typeface="Helvetica Neue"/>
-              </a:rPr>
-              <a:t>If you remember one slide, remember this map. It is the shape of every model you will build.</a:t>
+          <p:cNvPr id="7" name="TextBox 6"/>
+          <p:cNvSpPr txBox="1"/>
+          <p:nvPr/>
+        </p:nvSpPr>
+        <p:spPr>
+          <a:xfrm>
+            <a:off x="640080" y="5577840"/>
+            <a:ext cx="10881360" cy="457200"/>
+          </a:xfrm>
+          <a:prstGeom prst="rect">
+            <a:avLst/>
+          </a:prstGeom>
+          <a:noFill/>
+        </p:spPr>
+        <p:txBody>
+          <a:bodyPr wrap="square">
+            <a:spAutoFit/>
+          </a:bodyPr>
+          <a:lstStyle/>
+          <a:p>
+            <a:pPr algn="ctr"/>
+            <a:r>
+              <a:rPr sz="1400" b="0" i="1">
+                <a:solidFill>
+                  <a:srgbClr val="475569"/>
+                </a:solidFill>
+                <a:latin typeface="Helvetica Neue"/>
+              </a:rPr>
+              <a:t>Same block, same attention. What differs is whether the model looks only backward (to generate) or at the whole input at once (to read).</a:t>
             </a:r>
           </a:p>
         </p:txBody>
@@ -6705,6 +6628,266 @@
 </file>
 
 <file path=ppt/slides/slide17.xml><?xml version="1.0" encoding="utf-8"?>
+<p:sld xmlns:a="http://schemas.openxmlformats.org/drawingml/2006/main" xmlns:p="http://schemas.openxmlformats.org/presentationml/2006/main" xmlns:r="http://schemas.openxmlformats.org/officeDocument/2006/relationships">
+  <p:cSld>
+    <p:spTree>
+      <p:nvGrpSpPr>
+        <p:cNvPr id="1" name=""/>
+        <p:cNvGrpSpPr/>
+        <p:nvPr/>
+      </p:nvGrpSpPr>
+      <p:grpSpPr/>
+      <p:sp>
+        <p:nvSpPr>
+          <p:cNvPr id="2" name="TextBox 1"/>
+          <p:cNvSpPr txBox="1"/>
+          <p:nvPr/>
+        </p:nvSpPr>
+        <p:spPr>
+          <a:xfrm>
+            <a:off x="640080" y="457200"/>
+            <a:ext cx="6766560" cy="274320"/>
+          </a:xfrm>
+          <a:prstGeom prst="rect">
+            <a:avLst/>
+          </a:prstGeom>
+          <a:noFill/>
+        </p:spPr>
+        <p:txBody>
+          <a:bodyPr wrap="square">
+            <a:spAutoFit/>
+          </a:bodyPr>
+          <a:lstStyle/>
+          <a:p>
+            <a:pPr algn="l"/>
+            <a:r>
+              <a:rPr sz="1250" b="1" i="0" spc="220">
+                <a:solidFill>
+                  <a:srgbClr val="4F46E5"/>
+                </a:solidFill>
+                <a:latin typeface="Helvetica Neue"/>
+              </a:rPr>
+              <a:t>THE TAKEAWAY</a:t>
+            </a:r>
+          </a:p>
+        </p:txBody>
+      </p:sp>
+      <p:sp>
+        <p:nvSpPr>
+          <p:cNvPr id="3" name="TextBox 2"/>
+          <p:cNvSpPr txBox="1"/>
+          <p:nvPr/>
+        </p:nvSpPr>
+        <p:spPr>
+          <a:xfrm>
+            <a:off x="640080" y="758952"/>
+            <a:ext cx="10972800" cy="685800"/>
+          </a:xfrm>
+          <a:prstGeom prst="rect">
+            <a:avLst/>
+          </a:prstGeom>
+          <a:noFill/>
+        </p:spPr>
+        <p:txBody>
+          <a:bodyPr wrap="square">
+            <a:spAutoFit/>
+          </a:bodyPr>
+          <a:lstStyle/>
+          <a:p>
+            <a:pPr algn="l"/>
+            <a:r>
+              <a:rPr sz="2900" b="1" i="0">
+                <a:solidFill>
+                  <a:srgbClr val="0F172A"/>
+                </a:solidFill>
+                <a:latin typeface="Helvetica Neue"/>
+              </a:rPr>
+              <a:t>You can now name every step.</a:t>
+            </a:r>
+          </a:p>
+        </p:txBody>
+      </p:sp>
+      <p:sp>
+        <p:nvSpPr>
+          <p:cNvPr id="4" name="TextBox 3"/>
+          <p:cNvSpPr txBox="1"/>
+          <p:nvPr/>
+        </p:nvSpPr>
+        <p:spPr>
+          <a:xfrm>
+            <a:off x="640080" y="6492240"/>
+            <a:ext cx="8229600" cy="274320"/>
+          </a:xfrm>
+          <a:prstGeom prst="rect">
+            <a:avLst/>
+          </a:prstGeom>
+          <a:noFill/>
+        </p:spPr>
+        <p:txBody>
+          <a:bodyPr wrap="square">
+            <a:spAutoFit/>
+          </a:bodyPr>
+          <a:lstStyle/>
+          <a:p>
+            <a:pPr algn="l"/>
+            <a:r>
+              <a:rPr sz="900" b="0" i="0">
+                <a:solidFill>
+                  <a:srgbClr val="BCC1CC"/>
+                </a:solidFill>
+                <a:latin typeface="Helvetica Neue"/>
+              </a:rPr>
+              <a:t>ISBA 2411 · Natural Language Processing &amp; AI · Summer 2026</a:t>
+            </a:r>
+          </a:p>
+        </p:txBody>
+      </p:sp>
+      <p:pic>
+        <p:nvPicPr>
+          <p:cNvPr id="5" name="Picture 4" descr="hy_close.png"/>
+          <p:cNvPicPr>
+            <a:picLocks noChangeAspect="1"/>
+          </p:cNvPicPr>
+          <p:nvPr/>
+        </p:nvPicPr>
+        <p:blipFill>
+          <a:blip r:embed="rId2"/>
+          <a:stretch>
+            <a:fillRect/>
+          </a:stretch>
+        </p:blipFill>
+        <p:spPr>
+          <a:xfrm>
+            <a:off x="184251" y="2194560"/>
+            <a:ext cx="11823192" cy="631201"/>
+          </a:xfrm>
+          <a:prstGeom prst="rect">
+            <a:avLst/>
+          </a:prstGeom>
+        </p:spPr>
+      </p:pic>
+      <p:sp>
+        <p:nvSpPr>
+          <p:cNvPr id="6" name="TextBox 5"/>
+          <p:cNvSpPr txBox="1"/>
+          <p:nvPr/>
+        </p:nvSpPr>
+        <p:spPr>
+          <a:xfrm>
+            <a:off x="640080" y="3337560"/>
+            <a:ext cx="10607040" cy="914400"/>
+          </a:xfrm>
+          <a:prstGeom prst="rect">
+            <a:avLst/>
+          </a:prstGeom>
+          <a:noFill/>
+        </p:spPr>
+        <p:txBody>
+          <a:bodyPr wrap="square">
+            <a:spAutoFit/>
+          </a:bodyPr>
+          <a:lstStyle/>
+          <a:p>
+            <a:pPr algn="l"/>
+            <a:r>
+              <a:rPr sz="1700" b="0" i="0">
+                <a:solidFill>
+                  <a:srgbClr val="334155"/>
+                </a:solidFill>
+                <a:latin typeface="Helvetica Neue"/>
+              </a:rPr>
+              <a:t>One cost to carry forward: every token attends to every other token, so the work grows with the square of the sequence length. That is why context windows are precious, and it is next week's problem: retrieval and RAG.</a:t>
+            </a:r>
+          </a:p>
+        </p:txBody>
+      </p:sp>
+      <p:sp>
+        <p:nvSpPr>
+          <p:cNvPr id="7" name="Rectangle 6"/>
+          <p:cNvSpPr/>
+          <p:nvPr/>
+        </p:nvSpPr>
+        <p:spPr>
+          <a:xfrm>
+            <a:off x="658368" y="4617720"/>
+            <a:ext cx="822960" cy="54864"/>
+          </a:xfrm>
+          <a:prstGeom prst="rect">
+            <a:avLst/>
+          </a:prstGeom>
+          <a:solidFill>
+            <a:srgbClr val="E11D48"/>
+          </a:solidFill>
+          <a:ln>
+            <a:noFill/>
+          </a:ln>
+        </p:spPr>
+        <p:style>
+          <a:lnRef idx="1">
+            <a:schemeClr val="accent1"/>
+          </a:lnRef>
+          <a:fillRef idx="3">
+            <a:schemeClr val="accent1"/>
+          </a:fillRef>
+          <a:effectRef idx="2">
+            <a:schemeClr val="accent1"/>
+          </a:effectRef>
+          <a:fontRef idx="minor">
+            <a:schemeClr val="lt1"/>
+          </a:fontRef>
+        </p:style>
+        <p:txBody>
+          <a:bodyPr rtlCol="0" anchor="ctr"/>
+          <a:lstStyle/>
+          <a:p>
+            <a:pPr algn="ctr"/>
+          </a:p>
+        </p:txBody>
+      </p:sp>
+      <p:sp>
+        <p:nvSpPr>
+          <p:cNvPr id="8" name="TextBox 7"/>
+          <p:cNvSpPr txBox="1"/>
+          <p:nvPr/>
+        </p:nvSpPr>
+        <p:spPr>
+          <a:xfrm>
+            <a:off x="640080" y="4800600"/>
+            <a:ext cx="10515600" cy="457200"/>
+          </a:xfrm>
+          <a:prstGeom prst="rect">
+            <a:avLst/>
+          </a:prstGeom>
+          <a:noFill/>
+        </p:spPr>
+        <p:txBody>
+          <a:bodyPr wrap="square">
+            <a:spAutoFit/>
+          </a:bodyPr>
+          <a:lstStyle/>
+          <a:p>
+            <a:pPr algn="l"/>
+            <a:r>
+              <a:rPr sz="1700" b="0" i="1">
+                <a:solidFill>
+                  <a:srgbClr val="0F172A"/>
+                </a:solidFill>
+                <a:latin typeface="Helvetica Neue"/>
+              </a:rPr>
+              <a:t>If you remember one slide, remember this map. It is the shape of every model you will build.</a:t>
+            </a:r>
+          </a:p>
+        </p:txBody>
+      </p:sp>
+    </p:spTree>
+  </p:cSld>
+  <p:clrMapOvr>
+    <a:masterClrMapping/>
+  </p:clrMapOvr>
+</p:sld>
+</file>
+
+<file path=ppt/slides/slide18.xml><?xml version="1.0" encoding="utf-8"?>
 <p:sld xmlns:a="http://schemas.openxmlformats.org/drawingml/2006/main" xmlns:p="http://schemas.openxmlformats.org/presentationml/2006/main" xmlns:r="http://schemas.openxmlformats.org/officeDocument/2006/relationships">
   <p:cSld>
     <p:spTree>

</xml_diff>

<commit_message>
Week 6: update L11 deck (19 slides) + add transformer anatomy handout PDF
Deck adds the 'Why this matters at work' business-relevance slide and a
full-detail transformer anatomy reference slide; the anatomy poster is also
provided as a standalone one-page PDF handout for students.

Co-Authored-By: Claude Opus 4.8 <noreply@anthropic.com>
</commit_message>
<xml_diff>
--- a/Week 6/L11_Forward_BuildItUp.pptx
+++ b/Week 6/L11_Forward_BuildItUp.pptx
@@ -23,6 +23,7 @@
     <p:sldId id="271" r:id="rId22"/>
     <p:sldId id="272" r:id="rId23"/>
     <p:sldId id="273" r:id="rId24"/>
+    <p:sldId id="274" r:id="rId25"/>
   </p:sldIdLst>
   <p:sldSz cx="12191695" cy="6858000" type="screen4x3"/>
   <p:notesSz cx="6858000" cy="9144000"/>
@@ -6086,7 +6087,7 @@
                 </a:solidFill>
                 <a:latin typeface="Helvetica Neue"/>
               </a:rPr>
-              <a:t>THE WHOLE TRANSFORMER</a:t>
+              <a:t>AT SCALE</a:t>
             </a:r>
           </a:p>
         </p:txBody>
@@ -6121,7 +6122,7 @@
                 </a:solidFill>
                 <a:latin typeface="Helvetica Neue"/>
               </a:rPr>
-              <a:t>One full pass, end to end.</a:t>
+              <a:t>What makes production models fast and long.</a:t>
             </a:r>
           </a:p>
         </p:txBody>
@@ -6156,7 +6157,7 @@
                 </a:solidFill>
                 <a:latin typeface="Helvetica Neue"/>
               </a:rPr>
-              <a:t>Text becomes tokens, then vectors; the stack refines them; the head names the next word; the loop writes the rest.</a:t>
+              <a:t>The 2017 mechanism, plus a decade of engineering to serve millions of tokens.</a:t>
             </a:r>
           </a:p>
         </p:txBody>
@@ -6198,7 +6199,7 @@
       </p:sp>
       <p:pic>
         <p:nvPicPr>
-          <p:cNvPr id="6" name="Picture 5" descr="ff_flow.png"/>
+          <p:cNvPr id="6" name="Picture 5" descr="hy_scale.png"/>
           <p:cNvPicPr>
             <a:picLocks noChangeAspect="1"/>
           </p:cNvPicPr>
@@ -6212,8 +6213,8 @@
         </p:blipFill>
         <p:spPr>
           <a:xfrm>
-            <a:off x="518007" y="2926080"/>
-            <a:ext cx="11155680" cy="2592621"/>
+            <a:off x="518007" y="2286000"/>
+            <a:ext cx="11155680" cy="2092264"/>
           </a:xfrm>
           <a:prstGeom prst="rect">
             <a:avLst/>
@@ -6268,7 +6269,7 @@
                 </a:solidFill>
                 <a:latin typeface="Helvetica Neue"/>
               </a:rPr>
-              <a:t>AT SCALE</a:t>
+              <a:t>MODEL FAMILIES</a:t>
             </a:r>
           </a:p>
         </p:txBody>
@@ -6303,7 +6304,7 @@
                 </a:solidFill>
                 <a:latin typeface="Helvetica Neue"/>
               </a:rPr>
-              <a:t>What makes production models fast and long.</a:t>
+              <a:t>Encoder, decoder, encoder-decoder.</a:t>
             </a:r>
           </a:p>
         </p:txBody>
@@ -6338,7 +6339,7 @@
                 </a:solidFill>
                 <a:latin typeface="Helvetica Neue"/>
               </a:rPr>
-              <a:t>The 2017 mechanism, plus a decade of engineering to serve millions of tokens.</a:t>
+              <a:t>Every transformer is one of three shapes. You have already used two of them.</a:t>
             </a:r>
           </a:p>
         </p:txBody>
@@ -6380,7 +6381,7 @@
       </p:sp>
       <p:pic>
         <p:nvPicPr>
-          <p:cNvPr id="6" name="Picture 5" descr="hy_scale.png"/>
+          <p:cNvPr id="6" name="Picture 5" descr="hy_family.png"/>
           <p:cNvPicPr>
             <a:picLocks noChangeAspect="1"/>
           </p:cNvPicPr>
@@ -6394,14 +6395,49 @@
         </p:blipFill>
         <p:spPr>
           <a:xfrm>
-            <a:off x="518007" y="2286000"/>
-            <a:ext cx="11155680" cy="2092264"/>
+            <a:off x="518007" y="2331720"/>
+            <a:ext cx="11155680" cy="1792224"/>
           </a:xfrm>
           <a:prstGeom prst="rect">
             <a:avLst/>
           </a:prstGeom>
         </p:spPr>
       </p:pic>
+      <p:sp>
+        <p:nvSpPr>
+          <p:cNvPr id="7" name="TextBox 6"/>
+          <p:cNvSpPr txBox="1"/>
+          <p:nvPr/>
+        </p:nvSpPr>
+        <p:spPr>
+          <a:xfrm>
+            <a:off x="640080" y="5577840"/>
+            <a:ext cx="10881360" cy="457200"/>
+          </a:xfrm>
+          <a:prstGeom prst="rect">
+            <a:avLst/>
+          </a:prstGeom>
+          <a:noFill/>
+        </p:spPr>
+        <p:txBody>
+          <a:bodyPr wrap="square">
+            <a:spAutoFit/>
+          </a:bodyPr>
+          <a:lstStyle/>
+          <a:p>
+            <a:pPr algn="ctr"/>
+            <a:r>
+              <a:rPr sz="1400" b="0" i="1">
+                <a:solidFill>
+                  <a:srgbClr val="475569"/>
+                </a:solidFill>
+                <a:latin typeface="Helvetica Neue"/>
+              </a:rPr>
+              <a:t>Same block, same attention. What differs is whether the model looks only backward (to generate) or at the whole input at once (to read).</a:t>
+            </a:r>
+          </a:p>
+        </p:txBody>
+      </p:sp>
     </p:spTree>
   </p:cSld>
   <p:clrMapOvr>
@@ -6450,7 +6486,7 @@
                 </a:solidFill>
                 <a:latin typeface="Helvetica Neue"/>
               </a:rPr>
-              <a:t>MODEL FAMILIES</a:t>
+              <a:t>THE TAKEAWAY</a:t>
             </a:r>
           </a:p>
         </p:txBody>
@@ -6485,7 +6521,7 @@
                 </a:solidFill>
                 <a:latin typeface="Helvetica Neue"/>
               </a:rPr>
-              <a:t>Encoder, decoder, encoder-decoder.</a:t>
+              <a:t>You can now name every step.</a:t>
             </a:r>
           </a:p>
         </p:txBody>
@@ -6493,41 +6529,6 @@
       <p:sp>
         <p:nvSpPr>
           <p:cNvPr id="4" name="TextBox 3"/>
-          <p:cNvSpPr txBox="1"/>
-          <p:nvPr/>
-        </p:nvSpPr>
-        <p:spPr>
-          <a:xfrm>
-            <a:off x="640080" y="1417320"/>
-            <a:ext cx="10424160" cy="457200"/>
-          </a:xfrm>
-          <a:prstGeom prst="rect">
-            <a:avLst/>
-          </a:prstGeom>
-          <a:noFill/>
-        </p:spPr>
-        <p:txBody>
-          <a:bodyPr wrap="square">
-            <a:spAutoFit/>
-          </a:bodyPr>
-          <a:lstStyle/>
-          <a:p>
-            <a:pPr algn="l"/>
-            <a:r>
-              <a:rPr sz="1500" b="0" i="0">
-                <a:solidFill>
-                  <a:srgbClr val="475569"/>
-                </a:solidFill>
-                <a:latin typeface="Helvetica Neue"/>
-              </a:rPr>
-              <a:t>Every transformer is one of three shapes. You have already used two of them.</a:t>
-            </a:r>
-          </a:p>
-        </p:txBody>
-      </p:sp>
-      <p:sp>
-        <p:nvSpPr>
-          <p:cNvPr id="5" name="TextBox 4"/>
           <p:cNvSpPr txBox="1"/>
           <p:nvPr/>
         </p:nvSpPr>
@@ -6562,7 +6563,7 @@
       </p:sp>
       <p:pic>
         <p:nvPicPr>
-          <p:cNvPr id="6" name="Picture 5" descr="hy_family.png"/>
+          <p:cNvPr id="5" name="Picture 4" descr="hy_close.png"/>
           <p:cNvPicPr>
             <a:picLocks noChangeAspect="1"/>
           </p:cNvPicPr>
@@ -6576,8 +6577,8 @@
         </p:blipFill>
         <p:spPr>
           <a:xfrm>
-            <a:off x="518007" y="2331720"/>
-            <a:ext cx="11155680" cy="1792224"/>
+            <a:off x="184251" y="2194560"/>
+            <a:ext cx="11823192" cy="631201"/>
           </a:xfrm>
           <a:prstGeom prst="rect">
             <a:avLst/>
@@ -6586,35 +6587,113 @@
       </p:pic>
       <p:sp>
         <p:nvSpPr>
-          <p:cNvPr id="7" name="TextBox 6"/>
-          <p:cNvSpPr txBox="1"/>
-          <p:nvPr/>
-        </p:nvSpPr>
-        <p:spPr>
-          <a:xfrm>
-            <a:off x="640080" y="5577840"/>
-            <a:ext cx="10881360" cy="457200"/>
-          </a:xfrm>
-          <a:prstGeom prst="rect">
-            <a:avLst/>
-          </a:prstGeom>
-          <a:noFill/>
-        </p:spPr>
-        <p:txBody>
-          <a:bodyPr wrap="square">
-            <a:spAutoFit/>
-          </a:bodyPr>
-          <a:lstStyle/>
-          <a:p>
-            <a:pPr algn="ctr"/>
-            <a:r>
-              <a:rPr sz="1400" b="0" i="1">
-                <a:solidFill>
-                  <a:srgbClr val="475569"/>
-                </a:solidFill>
-                <a:latin typeface="Helvetica Neue"/>
-              </a:rPr>
-              <a:t>Same block, same attention. What differs is whether the model looks only backward (to generate) or at the whole input at once (to read).</a:t>
+          <p:cNvPr id="6" name="TextBox 5"/>
+          <p:cNvSpPr txBox="1"/>
+          <p:nvPr/>
+        </p:nvSpPr>
+        <p:spPr>
+          <a:xfrm>
+            <a:off x="640080" y="3337560"/>
+            <a:ext cx="10607040" cy="914400"/>
+          </a:xfrm>
+          <a:prstGeom prst="rect">
+            <a:avLst/>
+          </a:prstGeom>
+          <a:noFill/>
+        </p:spPr>
+        <p:txBody>
+          <a:bodyPr wrap="square">
+            <a:spAutoFit/>
+          </a:bodyPr>
+          <a:lstStyle/>
+          <a:p>
+            <a:pPr algn="l"/>
+            <a:r>
+              <a:rPr sz="1700" b="0" i="0">
+                <a:solidFill>
+                  <a:srgbClr val="334155"/>
+                </a:solidFill>
+                <a:latin typeface="Helvetica Neue"/>
+              </a:rPr>
+              <a:t>One cost to carry forward: every token attends to every other token, so the work grows with the square of the sequence length. That is why context windows are precious, and it is next week's problem: retrieval and RAG.</a:t>
+            </a:r>
+          </a:p>
+        </p:txBody>
+      </p:sp>
+      <p:sp>
+        <p:nvSpPr>
+          <p:cNvPr id="7" name="Rectangle 6"/>
+          <p:cNvSpPr/>
+          <p:nvPr/>
+        </p:nvSpPr>
+        <p:spPr>
+          <a:xfrm>
+            <a:off x="658368" y="4617720"/>
+            <a:ext cx="822960" cy="54864"/>
+          </a:xfrm>
+          <a:prstGeom prst="rect">
+            <a:avLst/>
+          </a:prstGeom>
+          <a:solidFill>
+            <a:srgbClr val="E11D48"/>
+          </a:solidFill>
+          <a:ln>
+            <a:noFill/>
+          </a:ln>
+        </p:spPr>
+        <p:style>
+          <a:lnRef idx="1">
+            <a:schemeClr val="accent1"/>
+          </a:lnRef>
+          <a:fillRef idx="3">
+            <a:schemeClr val="accent1"/>
+          </a:fillRef>
+          <a:effectRef idx="2">
+            <a:schemeClr val="accent1"/>
+          </a:effectRef>
+          <a:fontRef idx="minor">
+            <a:schemeClr val="lt1"/>
+          </a:fontRef>
+        </p:style>
+        <p:txBody>
+          <a:bodyPr rtlCol="0" anchor="ctr"/>
+          <a:lstStyle/>
+          <a:p>
+            <a:pPr algn="ctr"/>
+          </a:p>
+        </p:txBody>
+      </p:sp>
+      <p:sp>
+        <p:nvSpPr>
+          <p:cNvPr id="8" name="TextBox 7"/>
+          <p:cNvSpPr txBox="1"/>
+          <p:nvPr/>
+        </p:nvSpPr>
+        <p:spPr>
+          <a:xfrm>
+            <a:off x="640080" y="4800600"/>
+            <a:ext cx="10515600" cy="457200"/>
+          </a:xfrm>
+          <a:prstGeom prst="rect">
+            <a:avLst/>
+          </a:prstGeom>
+          <a:noFill/>
+        </p:spPr>
+        <p:txBody>
+          <a:bodyPr wrap="square">
+            <a:spAutoFit/>
+          </a:bodyPr>
+          <a:lstStyle/>
+          <a:p>
+            <a:pPr algn="l"/>
+            <a:r>
+              <a:rPr sz="1700" b="0" i="1">
+                <a:solidFill>
+                  <a:srgbClr val="0F172A"/>
+                </a:solidFill>
+                <a:latin typeface="Helvetica Neue"/>
+              </a:rPr>
+              <a:t>If you remember one slide, remember this map. It is the shape of every model you will build.</a:t>
             </a:r>
           </a:p>
         </p:txBody>
@@ -6667,7 +6746,7 @@
                 </a:solidFill>
                 <a:latin typeface="Helvetica Neue"/>
               </a:rPr>
-              <a:t>THE TAKEAWAY</a:t>
+              <a:t>WHY THIS MATTERS AT WORK</a:t>
             </a:r>
           </a:p>
         </p:txBody>
@@ -6702,7 +6781,7 @@
                 </a:solidFill>
                 <a:latin typeface="Helvetica Neue"/>
               </a:rPr>
-              <a:t>You can now name every step.</a:t>
+              <a:t>You learned business instincts, not trivia.</a:t>
             </a:r>
           </a:p>
         </p:txBody>
@@ -6710,6 +6789,41 @@
       <p:sp>
         <p:nvSpPr>
           <p:cNvPr id="4" name="TextBox 3"/>
+          <p:cNvSpPr txBox="1"/>
+          <p:nvPr/>
+        </p:nvSpPr>
+        <p:spPr>
+          <a:xfrm>
+            <a:off x="640080" y="1417320"/>
+            <a:ext cx="10424160" cy="457200"/>
+          </a:xfrm>
+          <a:prstGeom prst="rect">
+            <a:avLst/>
+          </a:prstGeom>
+          <a:noFill/>
+        </p:spPr>
+        <p:txBody>
+          <a:bodyPr wrap="square">
+            <a:spAutoFit/>
+          </a:bodyPr>
+          <a:lstStyle/>
+          <a:p>
+            <a:pPr algn="l"/>
+            <a:r>
+              <a:rPr sz="1500" b="0" i="0">
+                <a:solidFill>
+                  <a:srgbClr val="475569"/>
+                </a:solidFill>
+                <a:latin typeface="Helvetica Neue"/>
+              </a:rPr>
+              <a:t>Every step today is a call your future team needs someone in the room able to make.</a:t>
+            </a:r>
+          </a:p>
+        </p:txBody>
+      </p:sp>
+      <p:sp>
+        <p:nvSpPr>
+          <p:cNvPr id="5" name="TextBox 4"/>
           <p:cNvSpPr txBox="1"/>
           <p:nvPr/>
         </p:nvSpPr>
@@ -6744,7 +6858,7 @@
       </p:sp>
       <p:pic>
         <p:nvPicPr>
-          <p:cNvPr id="5" name="Picture 4" descr="hy_close.png"/>
+          <p:cNvPr id="6" name="Picture 5" descr="wk_work.png"/>
           <p:cNvPicPr>
             <a:picLocks noChangeAspect="1"/>
           </p:cNvPicPr>
@@ -6758,127 +6872,14 @@
         </p:blipFill>
         <p:spPr>
           <a:xfrm>
-            <a:off x="184251" y="2194560"/>
-            <a:ext cx="11823192" cy="631201"/>
+            <a:off x="518007" y="1965960"/>
+            <a:ext cx="11155680" cy="4339438"/>
           </a:xfrm>
           <a:prstGeom prst="rect">
             <a:avLst/>
           </a:prstGeom>
         </p:spPr>
       </p:pic>
-      <p:sp>
-        <p:nvSpPr>
-          <p:cNvPr id="6" name="TextBox 5"/>
-          <p:cNvSpPr txBox="1"/>
-          <p:nvPr/>
-        </p:nvSpPr>
-        <p:spPr>
-          <a:xfrm>
-            <a:off x="640080" y="3337560"/>
-            <a:ext cx="10607040" cy="914400"/>
-          </a:xfrm>
-          <a:prstGeom prst="rect">
-            <a:avLst/>
-          </a:prstGeom>
-          <a:noFill/>
-        </p:spPr>
-        <p:txBody>
-          <a:bodyPr wrap="square">
-            <a:spAutoFit/>
-          </a:bodyPr>
-          <a:lstStyle/>
-          <a:p>
-            <a:pPr algn="l"/>
-            <a:r>
-              <a:rPr sz="1700" b="0" i="0">
-                <a:solidFill>
-                  <a:srgbClr val="334155"/>
-                </a:solidFill>
-                <a:latin typeface="Helvetica Neue"/>
-              </a:rPr>
-              <a:t>One cost to carry forward: every token attends to every other token, so the work grows with the square of the sequence length. That is why context windows are precious, and it is next week's problem: retrieval and RAG.</a:t>
-            </a:r>
-          </a:p>
-        </p:txBody>
-      </p:sp>
-      <p:sp>
-        <p:nvSpPr>
-          <p:cNvPr id="7" name="Rectangle 6"/>
-          <p:cNvSpPr/>
-          <p:nvPr/>
-        </p:nvSpPr>
-        <p:spPr>
-          <a:xfrm>
-            <a:off x="658368" y="4617720"/>
-            <a:ext cx="822960" cy="54864"/>
-          </a:xfrm>
-          <a:prstGeom prst="rect">
-            <a:avLst/>
-          </a:prstGeom>
-          <a:solidFill>
-            <a:srgbClr val="E11D48"/>
-          </a:solidFill>
-          <a:ln>
-            <a:noFill/>
-          </a:ln>
-        </p:spPr>
-        <p:style>
-          <a:lnRef idx="1">
-            <a:schemeClr val="accent1"/>
-          </a:lnRef>
-          <a:fillRef idx="3">
-            <a:schemeClr val="accent1"/>
-          </a:fillRef>
-          <a:effectRef idx="2">
-            <a:schemeClr val="accent1"/>
-          </a:effectRef>
-          <a:fontRef idx="minor">
-            <a:schemeClr val="lt1"/>
-          </a:fontRef>
-        </p:style>
-        <p:txBody>
-          <a:bodyPr rtlCol="0" anchor="ctr"/>
-          <a:lstStyle/>
-          <a:p>
-            <a:pPr algn="ctr"/>
-          </a:p>
-        </p:txBody>
-      </p:sp>
-      <p:sp>
-        <p:nvSpPr>
-          <p:cNvPr id="8" name="TextBox 7"/>
-          <p:cNvSpPr txBox="1"/>
-          <p:nvPr/>
-        </p:nvSpPr>
-        <p:spPr>
-          <a:xfrm>
-            <a:off x="640080" y="4800600"/>
-            <a:ext cx="10515600" cy="457200"/>
-          </a:xfrm>
-          <a:prstGeom prst="rect">
-            <a:avLst/>
-          </a:prstGeom>
-          <a:noFill/>
-        </p:spPr>
-        <p:txBody>
-          <a:bodyPr wrap="square">
-            <a:spAutoFit/>
-          </a:bodyPr>
-          <a:lstStyle/>
-          <a:p>
-            <a:pPr algn="l"/>
-            <a:r>
-              <a:rPr sz="1700" b="0" i="1">
-                <a:solidFill>
-                  <a:srgbClr val="0F172A"/>
-                </a:solidFill>
-                <a:latin typeface="Helvetica Neue"/>
-              </a:rPr>
-              <a:t>If you remember one slide, remember this map. It is the shape of every model you will build.</a:t>
-            </a:r>
-          </a:p>
-        </p:txBody>
-      </p:sp>
     </p:spTree>
   </p:cSld>
   <p:clrMapOvr>
@@ -8402,6 +8403,188 @@
                 <a:hlinkClick r:id="rId14"/>
               </a:rPr>
               <a:t>app_reviews dataset (Google Play) on the Hugging Face Hub</a:t>
+            </a:r>
+          </a:p>
+        </p:txBody>
+      </p:sp>
+    </p:spTree>
+  </p:cSld>
+  <p:clrMapOvr>
+    <a:masterClrMapping/>
+  </p:clrMapOvr>
+</p:sld>
+</file>
+
+<file path=ppt/slides/slide19.xml><?xml version="1.0" encoding="utf-8"?>
+<p:sld xmlns:a="http://schemas.openxmlformats.org/drawingml/2006/main" xmlns:p="http://schemas.openxmlformats.org/presentationml/2006/main" xmlns:r="http://schemas.openxmlformats.org/officeDocument/2006/relationships">
+  <p:cSld>
+    <p:spTree>
+      <p:nvGrpSpPr>
+        <p:cNvPr id="1" name=""/>
+        <p:cNvGrpSpPr/>
+        <p:nvPr/>
+      </p:nvGrpSpPr>
+      <p:grpSpPr/>
+      <p:sp>
+        <p:nvSpPr>
+          <p:cNvPr id="2" name="TextBox 1"/>
+          <p:cNvSpPr txBox="1"/>
+          <p:nvPr/>
+        </p:nvSpPr>
+        <p:spPr>
+          <a:xfrm>
+            <a:off x="640080" y="457200"/>
+            <a:ext cx="6766560" cy="274320"/>
+          </a:xfrm>
+          <a:prstGeom prst="rect">
+            <a:avLst/>
+          </a:prstGeom>
+          <a:noFill/>
+        </p:spPr>
+        <p:txBody>
+          <a:bodyPr wrap="square">
+            <a:spAutoFit/>
+          </a:bodyPr>
+          <a:lstStyle/>
+          <a:p>
+            <a:pPr algn="l"/>
+            <a:r>
+              <a:rPr sz="1250" b="1" i="0" spc="220">
+                <a:solidFill>
+                  <a:srgbClr val="4F46E5"/>
+                </a:solidFill>
+                <a:latin typeface="Helvetica Neue"/>
+              </a:rPr>
+              <a:t>REFERENCE</a:t>
+            </a:r>
+          </a:p>
+        </p:txBody>
+      </p:sp>
+      <p:sp>
+        <p:nvSpPr>
+          <p:cNvPr id="3" name="TextBox 2"/>
+          <p:cNvSpPr txBox="1"/>
+          <p:nvPr/>
+        </p:nvSpPr>
+        <p:spPr>
+          <a:xfrm>
+            <a:off x="640080" y="758952"/>
+            <a:ext cx="10972800" cy="685800"/>
+          </a:xfrm>
+          <a:prstGeom prst="rect">
+            <a:avLst/>
+          </a:prstGeom>
+          <a:noFill/>
+        </p:spPr>
+        <p:txBody>
+          <a:bodyPr wrap="square">
+            <a:spAutoFit/>
+          </a:bodyPr>
+          <a:lstStyle/>
+          <a:p>
+            <a:pPr algn="l"/>
+            <a:r>
+              <a:rPr sz="2900" b="1" i="0">
+                <a:solidFill>
+                  <a:srgbClr val="0F172A"/>
+                </a:solidFill>
+                <a:latin typeface="Helvetica Neue"/>
+              </a:rPr>
+              <a:t>The transformer, in full detail.</a:t>
+            </a:r>
+          </a:p>
+        </p:txBody>
+      </p:sp>
+      <p:sp>
+        <p:nvSpPr>
+          <p:cNvPr id="4" name="TextBox 3"/>
+          <p:cNvSpPr txBox="1"/>
+          <p:nvPr/>
+        </p:nvSpPr>
+        <p:spPr>
+          <a:xfrm>
+            <a:off x="640080" y="6492240"/>
+            <a:ext cx="8229600" cy="274320"/>
+          </a:xfrm>
+          <a:prstGeom prst="rect">
+            <a:avLst/>
+          </a:prstGeom>
+          <a:noFill/>
+        </p:spPr>
+        <p:txBody>
+          <a:bodyPr wrap="square">
+            <a:spAutoFit/>
+          </a:bodyPr>
+          <a:lstStyle/>
+          <a:p>
+            <a:pPr algn="l"/>
+            <a:r>
+              <a:rPr sz="900" b="0" i="0">
+                <a:solidFill>
+                  <a:srgbClr val="BCC1CC"/>
+                </a:solidFill>
+                <a:latin typeface="Helvetica Neue"/>
+              </a:rPr>
+              <a:t>ISBA 2411 · Natural Language Processing &amp; AI · Summer 2026</a:t>
+            </a:r>
+          </a:p>
+        </p:txBody>
+      </p:sp>
+      <p:pic>
+        <p:nvPicPr>
+          <p:cNvPr id="5" name="Picture 4" descr="L11_Transformer_Anatomy.png"/>
+          <p:cNvPicPr>
+            <a:picLocks noChangeAspect="1"/>
+          </p:cNvPicPr>
+          <p:nvPr/>
+        </p:nvPicPr>
+        <p:blipFill>
+          <a:blip r:embed="rId2"/>
+          <a:stretch>
+            <a:fillRect/>
+          </a:stretch>
+        </p:blipFill>
+        <p:spPr>
+          <a:xfrm>
+            <a:off x="4151051" y="1554480"/>
+            <a:ext cx="3889592" cy="4617720"/>
+          </a:xfrm>
+          <a:prstGeom prst="rect">
+            <a:avLst/>
+          </a:prstGeom>
+        </p:spPr>
+      </p:pic>
+      <p:sp>
+        <p:nvSpPr>
+          <p:cNvPr id="6" name="TextBox 5"/>
+          <p:cNvSpPr txBox="1"/>
+          <p:nvPr/>
+        </p:nvSpPr>
+        <p:spPr>
+          <a:xfrm>
+            <a:off x="640080" y="6236208"/>
+            <a:ext cx="10881360" cy="320040"/>
+          </a:xfrm>
+          <a:prstGeom prst="rect">
+            <a:avLst/>
+          </a:prstGeom>
+          <a:noFill/>
+        </p:spPr>
+        <p:txBody>
+          <a:bodyPr wrap="square">
+            <a:spAutoFit/>
+          </a:bodyPr>
+          <a:lstStyle/>
+          <a:p>
+            <a:pPr algn="ctr"/>
+            <a:r>
+              <a:rPr sz="1300" b="0" i="1">
+                <a:solidFill>
+                  <a:srgbClr val="475569"/>
+                </a:solidFill>
+                <a:latin typeface="Helvetica Neue"/>
+              </a:rPr>
+              <a:t>Every stage annotated with the classic technique and its modern replacement. Photograph it, or use the full-size PDF handout.</a:t>
             </a:r>
           </a:p>
         </p:txBody>

</xml_diff>